<commit_message>
docs(marketing): update TechTalk_ContractMgmt_AgenticAI deck
Co-authored-by: Copilot App <223556219+Copilot@users.noreply.github.com>

Copilot-Session: 0fac447f-3cf0-4144-a2ed-d08060ed7dbc
</commit_message>
<xml_diff>
--- a/docs/marketing/TechTalk_ContractMgmt_AgenticAI.pptx
+++ b/docs/marketing/TechTalk_ContractMgmt_AgenticAI.pptx
@@ -112,25 +112,17 @@
 </p:presentation>
 </file>
 
-<file path=ppt/revisionInfo.xml><?xml version="1.0" encoding="utf-8"?>
-<p1510:revInfo xmlns:a="http://schemas.openxmlformats.org/drawingml/2006/main" xmlns:r="http://schemas.openxmlformats.org/officeDocument/2006/relationships" xmlns:p1510="http://schemas.microsoft.com/office/powerpoint/2015/10/main">
-  <p1510:revLst>
-    <p1510:client id="{AB8CF1AA-6DCA-459E-9B64-2959834C4AF0}" v="3" dt="2026-07-29T18:40:24.802"/>
-  </p1510:revLst>
-</p1510:revInfo>
-</file>
-
 <file path=ppt/changesInfos/changesInfo1.xml><?xml version="1.0" encoding="utf-8"?>
 <pc:chgInfo xmlns:a="http://schemas.openxmlformats.org/drawingml/2006/main" xmlns:r="http://schemas.openxmlformats.org/officeDocument/2006/relationships" xmlns:ac="http://schemas.microsoft.com/office/drawing/2013/main/command" xmlns:pc="http://schemas.microsoft.com/office/powerpoint/2013/main/command">
   <pc:docChgLst>
     <pc:chgData name="Glejdis Shkembi" userId="1c63e9c2-f066-4d08-a46c-6f3c67414dab" providerId="ADAL" clId="{D59F3545-C3AF-42EE-AFFA-D09C72A691CB}"/>
     <pc:docChg chg="undo custSel modSld">
-      <pc:chgData name="Glejdis Shkembi" userId="1c63e9c2-f066-4d08-a46c-6f3c67414dab" providerId="ADAL" clId="{D59F3545-C3AF-42EE-AFFA-D09C72A691CB}" dt="2026-07-29T18:41:58.234" v="68" actId="14100"/>
+      <pc:chgData name="Glejdis Shkembi" userId="1c63e9c2-f066-4d08-a46c-6f3c67414dab" providerId="ADAL" clId="{D59F3545-C3AF-42EE-AFFA-D09C72A691CB}" dt="2026-08-03T17:01:50.495" v="97" actId="20577"/>
       <pc:docMkLst>
         <pc:docMk/>
       </pc:docMkLst>
       <pc:sldChg chg="modSp mod">
-        <pc:chgData name="Glejdis Shkembi" userId="1c63e9c2-f066-4d08-a46c-6f3c67414dab" providerId="ADAL" clId="{D59F3545-C3AF-42EE-AFFA-D09C72A691CB}" dt="2026-07-29T18:41:58.234" v="68" actId="14100"/>
+        <pc:chgData name="Glejdis Shkembi" userId="1c63e9c2-f066-4d08-a46c-6f3c67414dab" providerId="ADAL" clId="{D59F3545-C3AF-42EE-AFFA-D09C72A691CB}" dt="2026-08-03T17:01:50.495" v="97" actId="20577"/>
         <pc:sldMkLst>
           <pc:docMk/>
           <pc:sldMk cId="0" sldId="256"/>
@@ -192,6 +184,14 @@
           </ac:spMkLst>
         </pc:spChg>
         <pc:spChg chg="mod">
+          <ac:chgData name="Glejdis Shkembi" userId="1c63e9c2-f066-4d08-a46c-6f3c67414dab" providerId="ADAL" clId="{D59F3545-C3AF-42EE-AFFA-D09C72A691CB}" dt="2026-08-03T12:36:01.125" v="75" actId="20577"/>
+          <ac:spMkLst>
+            <pc:docMk/>
+            <pc:sldMk cId="0" sldId="256"/>
+            <ac:spMk id="19" creationId="{00000000-0000-0000-0000-000000000000}"/>
+          </ac:spMkLst>
+        </pc:spChg>
+        <pc:spChg chg="mod">
           <ac:chgData name="Glejdis Shkembi" userId="1c63e9c2-f066-4d08-a46c-6f3c67414dab" providerId="ADAL" clId="{D59F3545-C3AF-42EE-AFFA-D09C72A691CB}" dt="2026-07-29T18:41:26.321" v="29" actId="1036"/>
           <ac:spMkLst>
             <pc:docMk/>
@@ -221,6 +221,14 @@
             <pc:docMk/>
             <pc:sldMk cId="0" sldId="256"/>
             <ac:spMk id="23" creationId="{00000000-0000-0000-0000-000000000000}"/>
+          </ac:spMkLst>
+        </pc:spChg>
+        <pc:spChg chg="mod">
+          <ac:chgData name="Glejdis Shkembi" userId="1c63e9c2-f066-4d08-a46c-6f3c67414dab" providerId="ADAL" clId="{D59F3545-C3AF-42EE-AFFA-D09C72A691CB}" dt="2026-08-03T17:01:50.495" v="97" actId="20577"/>
+          <ac:spMkLst>
+            <pc:docMk/>
+            <pc:sldMk cId="0" sldId="256"/>
+            <ac:spMk id="25" creationId="{00000000-0000-0000-0000-000000000000}"/>
           </ac:spMkLst>
         </pc:spChg>
         <pc:spChg chg="mod">
@@ -1751,7 +1759,7 @@
                 <a:ea typeface="Segoe UI" pitchFamily="34" charset="-122"/>
                 <a:cs typeface="Segoe UI" pitchFamily="34" charset="-120"/>
               </a:rPr>
-              <a:t>Claude Opus 4.8</a:t>
+              <a:t>GPT-5.4</a:t>
             </a:r>
             <a:endParaRPr lang="en-US" sz="950" dirty="0"/>
           </a:p>
@@ -2007,7 +2015,7 @@
               <a:buNone/>
             </a:pPr>
             <a:r>
-              <a:rPr lang="en-US" sz="750" b="1" dirty="0">
+              <a:rPr lang="en-US" sz="750" b="1">
                 <a:solidFill>
                   <a:srgbClr val="CFE0F2"/>
                 </a:solidFill>
@@ -2015,7 +2023,7 @@
                 <a:ea typeface="Segoe UI" pitchFamily="34" charset="-122"/>
                 <a:cs typeface="Segoe UI" pitchFamily="34" charset="-120"/>
               </a:rPr>
-              <a:t>GPT-5-mini</a:t>
+              <a:t>GPT-5.4-nano</a:t>
             </a:r>
             <a:endParaRPr lang="en-US" sz="950" dirty="0"/>
           </a:p>

</xml_diff>